<commit_message>
chore: add German comments and descriptions to various components for better clarity
</commit_message>
<xml_diff>
--- a/_doku/Praesentation_TwitchLandingpage_v3.pptx
+++ b/_doku/Praesentation_TwitchLandingpage_v3.pptx
@@ -310,7 +310,7 @@
           <a:p>
             <a:fld id="{5BCAD085-E8A6-8845-BD4E-CB4CCA059FC4}" type="datetimeFigureOut">
               <a:rPr lang="en-US" smtClean="0"/>
-              <a:t>5/11/2026</a:t>
+              <a:t>5/14/2026</a:t>
             </a:fld>
             <a:endParaRPr lang="en-US"/>
           </a:p>
@@ -478,7 +478,7 @@
           <a:p>
             <a:fld id="{5BCAD085-E8A6-8845-BD4E-CB4CCA059FC4}" type="datetimeFigureOut">
               <a:rPr lang="en-US" smtClean="0"/>
-              <a:t>5/11/2026</a:t>
+              <a:t>5/14/2026</a:t>
             </a:fld>
             <a:endParaRPr lang="en-US"/>
           </a:p>
@@ -656,7 +656,7 @@
           <a:p>
             <a:fld id="{5BCAD085-E8A6-8845-BD4E-CB4CCA059FC4}" type="datetimeFigureOut">
               <a:rPr lang="en-US" smtClean="0"/>
-              <a:t>5/11/2026</a:t>
+              <a:t>5/14/2026</a:t>
             </a:fld>
             <a:endParaRPr lang="en-US"/>
           </a:p>
@@ -824,7 +824,7 @@
           <a:p>
             <a:fld id="{5BCAD085-E8A6-8845-BD4E-CB4CCA059FC4}" type="datetimeFigureOut">
               <a:rPr lang="en-US" smtClean="0"/>
-              <a:t>5/11/2026</a:t>
+              <a:t>5/14/2026</a:t>
             </a:fld>
             <a:endParaRPr lang="en-US"/>
           </a:p>
@@ -1069,7 +1069,7 @@
           <a:p>
             <a:fld id="{5BCAD085-E8A6-8845-BD4E-CB4CCA059FC4}" type="datetimeFigureOut">
               <a:rPr lang="en-US" smtClean="0"/>
-              <a:t>5/11/2026</a:t>
+              <a:t>5/14/2026</a:t>
             </a:fld>
             <a:endParaRPr lang="en-US"/>
           </a:p>
@@ -1354,7 +1354,7 @@
           <a:p>
             <a:fld id="{5BCAD085-E8A6-8845-BD4E-CB4CCA059FC4}" type="datetimeFigureOut">
               <a:rPr lang="en-US" smtClean="0"/>
-              <a:t>5/11/2026</a:t>
+              <a:t>5/14/2026</a:t>
             </a:fld>
             <a:endParaRPr lang="en-US"/>
           </a:p>
@@ -1773,7 +1773,7 @@
           <a:p>
             <a:fld id="{5BCAD085-E8A6-8845-BD4E-CB4CCA059FC4}" type="datetimeFigureOut">
               <a:rPr lang="en-US" smtClean="0"/>
-              <a:t>5/11/2026</a:t>
+              <a:t>5/14/2026</a:t>
             </a:fld>
             <a:endParaRPr lang="en-US"/>
           </a:p>
@@ -1890,7 +1890,7 @@
           <a:p>
             <a:fld id="{5BCAD085-E8A6-8845-BD4E-CB4CCA059FC4}" type="datetimeFigureOut">
               <a:rPr lang="en-US" smtClean="0"/>
-              <a:t>5/11/2026</a:t>
+              <a:t>5/14/2026</a:t>
             </a:fld>
             <a:endParaRPr lang="en-US"/>
           </a:p>
@@ -1985,7 +1985,7 @@
           <a:p>
             <a:fld id="{5BCAD085-E8A6-8845-BD4E-CB4CCA059FC4}" type="datetimeFigureOut">
               <a:rPr lang="en-US" smtClean="0"/>
-              <a:t>5/11/2026</a:t>
+              <a:t>5/14/2026</a:t>
             </a:fld>
             <a:endParaRPr lang="en-US"/>
           </a:p>
@@ -2260,7 +2260,7 @@
           <a:p>
             <a:fld id="{5BCAD085-E8A6-8845-BD4E-CB4CCA059FC4}" type="datetimeFigureOut">
               <a:rPr lang="en-US" smtClean="0"/>
-              <a:t>5/11/2026</a:t>
+              <a:t>5/14/2026</a:t>
             </a:fld>
             <a:endParaRPr lang="en-US"/>
           </a:p>
@@ -2512,7 +2512,7 @@
           <a:p>
             <a:fld id="{5BCAD085-E8A6-8845-BD4E-CB4CCA059FC4}" type="datetimeFigureOut">
               <a:rPr lang="en-US" smtClean="0"/>
-              <a:t>5/11/2026</a:t>
+              <a:t>5/14/2026</a:t>
             </a:fld>
             <a:endParaRPr lang="en-US"/>
           </a:p>
@@ -2723,7 +2723,7 @@
           <a:p>
             <a:fld id="{5BCAD085-E8A6-8845-BD4E-CB4CCA059FC4}" type="datetimeFigureOut">
               <a:rPr lang="en-US" smtClean="0"/>
-              <a:t>5/11/2026</a:t>
+              <a:t>5/14/2026</a:t>
             </a:fld>
             <a:endParaRPr lang="en-US"/>
           </a:p>
@@ -7842,7 +7842,7 @@
         <p:spPr>
           <a:xfrm>
             <a:off x="548640" y="6446520"/>
-            <a:ext cx="11064240" cy="320040"/>
+            <a:ext cx="11064240" cy="169277"/>
           </a:xfrm>
           <a:prstGeom prst="rect">
             <a:avLst/>
@@ -7857,13 +7857,103 @@
           <a:p>
             <a:pPr algn="ctr"/>
             <a:r>
-              <a:rPr sz="1100" b="0" i="1">
+              <a:rPr sz="1100" b="0" i="1" dirty="0">
                 <a:solidFill>
                   <a:srgbClr val="554B6E"/>
                 </a:solidFill>
                 <a:latin typeface="Calibri"/>
               </a:rPr>
-              <a:t>Frontend ↔ Supabase  ·  TwitchAddon (Bun, Railway)  ·  DiscordBot (Render)  ·  pg_net Webhooks</a:t>
+              <a:t>Frontend ↔ </a:t>
+            </a:r>
+            <a:r>
+              <a:rPr sz="1100" b="0" i="1" dirty="0" err="1">
+                <a:solidFill>
+                  <a:srgbClr val="554B6E"/>
+                </a:solidFill>
+                <a:latin typeface="Calibri"/>
+              </a:rPr>
+              <a:t>Supabase</a:t>
+            </a:r>
+            <a:r>
+              <a:rPr sz="1100" b="0" i="1" dirty="0">
+                <a:solidFill>
+                  <a:srgbClr val="554B6E"/>
+                </a:solidFill>
+                <a:latin typeface="Calibri"/>
+              </a:rPr>
+              <a:t>  ·  </a:t>
+            </a:r>
+            <a:r>
+              <a:rPr sz="1100" b="0" i="1" dirty="0" err="1">
+                <a:solidFill>
+                  <a:srgbClr val="554B6E"/>
+                </a:solidFill>
+                <a:latin typeface="Calibri"/>
+              </a:rPr>
+              <a:t>TwitchAddon</a:t>
+            </a:r>
+            <a:r>
+              <a:rPr sz="1100" b="0" i="1" dirty="0">
+                <a:solidFill>
+                  <a:srgbClr val="554B6E"/>
+                </a:solidFill>
+                <a:latin typeface="Calibri"/>
+              </a:rPr>
+              <a:t> (Bun</a:t>
+            </a:r>
+            <a:r>
+              <a:rPr lang="de-DE" sz="1100" b="0" i="1" dirty="0">
+                <a:solidFill>
+                  <a:srgbClr val="554B6E"/>
+                </a:solidFill>
+                <a:latin typeface="Calibri"/>
+              </a:rPr>
+              <a:t>) </a:t>
+            </a:r>
+            <a:r>
+              <a:rPr sz="1100" b="0" i="1" dirty="0">
+                <a:solidFill>
+                  <a:srgbClr val="554B6E"/>
+                </a:solidFill>
+                <a:latin typeface="Calibri"/>
+              </a:rPr>
+              <a:t>·  </a:t>
+            </a:r>
+            <a:r>
+              <a:rPr sz="1100" b="0" i="1" dirty="0" err="1">
+                <a:solidFill>
+                  <a:srgbClr val="554B6E"/>
+                </a:solidFill>
+                <a:latin typeface="Calibri"/>
+              </a:rPr>
+              <a:t>DiscordBot</a:t>
+            </a:r>
+            <a:r>
+              <a:rPr sz="1100" b="0" i="1" dirty="0">
+                <a:solidFill>
+                  <a:srgbClr val="554B6E"/>
+                </a:solidFill>
+                <a:latin typeface="Calibri"/>
+              </a:rPr>
+              <a:t> (Render)  ·  </a:t>
+            </a:r>
+            <a:r>
+              <a:rPr sz="1100" b="0" i="1" dirty="0" err="1">
+                <a:solidFill>
+                  <a:srgbClr val="554B6E"/>
+                </a:solidFill>
+                <a:latin typeface="Calibri"/>
+              </a:rPr>
+              <a:t>pg_net</a:t>
+            </a:r>
+            <a:r>
+              <a:rPr sz="1100" b="0" i="1" dirty="0">
+                <a:solidFill>
+                  <a:srgbClr val="554B6E"/>
+                </a:solidFill>
+                <a:latin typeface="Calibri"/>
+              </a:rPr>
+              <a:t> Webhooks</a:t>
             </a:r>
           </a:p>
         </p:txBody>
@@ -7903,6 +7993,66 @@
           </a:p>
         </p:txBody>
       </p:sp>
+      <p:pic>
+        <p:nvPicPr>
+          <p:cNvPr id="10" name="Grafik 9">
+            <a:extLst>
+              <a:ext uri="{FF2B5EF4-FFF2-40B4-BE49-F238E27FC236}">
+                <a16:creationId xmlns:a16="http://schemas.microsoft.com/office/drawing/2014/main" id="{4BF36726-2D46-19DB-8C31-62134100B28E}"/>
+              </a:ext>
+            </a:extLst>
+          </p:cNvPr>
+          <p:cNvPicPr>
+            <a:picLocks noChangeAspect="1"/>
+          </p:cNvPicPr>
+          <p:nvPr/>
+        </p:nvPicPr>
+        <p:blipFill>
+          <a:blip r:embed="rId3"/>
+          <a:stretch>
+            <a:fillRect/>
+          </a:stretch>
+        </p:blipFill>
+        <p:spPr>
+          <a:xfrm>
+            <a:off x="7746158" y="3914777"/>
+            <a:ext cx="168269" cy="71457"/>
+          </a:xfrm>
+          <a:prstGeom prst="rect">
+            <a:avLst/>
+          </a:prstGeom>
+        </p:spPr>
+      </p:pic>
+      <p:pic>
+        <p:nvPicPr>
+          <p:cNvPr id="12" name="Grafik 11">
+            <a:extLst>
+              <a:ext uri="{FF2B5EF4-FFF2-40B4-BE49-F238E27FC236}">
+                <a16:creationId xmlns:a16="http://schemas.microsoft.com/office/drawing/2014/main" id="{E6EC975C-D8C6-0588-781F-0B0135AFEBCA}"/>
+              </a:ext>
+            </a:extLst>
+          </p:cNvPr>
+          <p:cNvPicPr>
+            <a:picLocks noChangeAspect="1"/>
+          </p:cNvPicPr>
+          <p:nvPr/>
+        </p:nvPicPr>
+        <p:blipFill>
+          <a:blip r:embed="rId4"/>
+          <a:stretch>
+            <a:fillRect/>
+          </a:stretch>
+        </p:blipFill>
+        <p:spPr>
+          <a:xfrm>
+            <a:off x="7812841" y="3917158"/>
+            <a:ext cx="285790" cy="71721"/>
+          </a:xfrm>
+          <a:prstGeom prst="rect">
+            <a:avLst/>
+          </a:prstGeom>
+        </p:spPr>
+      </p:pic>
     </p:spTree>
   </p:cSld>
   <p:clrMapOvr>

</xml_diff>